<commit_message>
Final pass: document the template, tidy click targets, update the guide
README gains a section describing the seven-slide system, the slide
map, the one-move theme recolour and how to regenerate from source —
previously the repo only documented the courtside app.

Section-head frames are now sized to their title instead of a blanket
4.8", and five other text frames were trimmed or nudged, so no two text
boxes on any slide share a click target. A new collision check joins
the bounds, id and colour checks; all pass across all seven slides.

Guide callouts (slide 3) now describe the setup / progression /
regression strip and point coaches to the control board, set pieces
and pocket cards.

Co-Authored-By: Claude Fable 5.1 <noreply@anthropic.com>
Claude-Session: https://claude.ai/code/session_018tafNEeKNQ7u7wPXfzwa7T
</commit_message>
<xml_diff>
--- a/futsal_session_template.pptx
+++ b/futsal_session_template.pptx
@@ -26162,7 +26162,7 @@
                 </a:solidFill>
                 <a:latin typeface="Calibri"/>
               </a:rPr>
-              <a:t>HOW TO — Use the notes strip for constraints, progressions and setup / equipment reminders.</a:t>
+              <a:t>HOW TO — Setup on the left. Pre-commit the harder and the easier version of every activity before you coach it.</a:t>
             </a:r>
           </a:p>
         </p:txBody>
@@ -26218,7 +26218,7 @@
                 </a:solidFill>
                 <a:latin typeface="Calibri"/>
               </a:rPr>
-              <a:t>HOW TO — Duplicate Slide 2 each week. Delete these blue notes — they are single text boxes.</a:t>
+              <a:t>HOW TO — Duplicate Slide 2 weekly. Slide 5 = load + rotations, 6 = set pieces, 7 = pocket cards. Delete these blue notes.</a:t>
             </a:r>
           </a:p>
         </p:txBody>
@@ -26442,7 +26442,7 @@
         <p:spPr>
           <a:xfrm>
             <a:off x="438912" y="658368"/>
-            <a:ext cx="4389120" cy="201168"/>
+            <a:ext cx="1869034" cy="201168"/>
           </a:xfrm>
           <a:prstGeom prst="rect">
             <a:avLst/>
@@ -26883,7 +26883,7 @@
         <p:spPr>
           <a:xfrm>
             <a:off x="2404872" y="658368"/>
-            <a:ext cx="4389120" cy="201168"/>
+            <a:ext cx="870509" cy="201168"/>
           </a:xfrm>
           <a:prstGeom prst="rect">
             <a:avLst/>
@@ -27158,7 +27158,7 @@
         </p:nvSpPr>
         <p:spPr>
           <a:xfrm>
-            <a:off x="3429000" y="685800"/>
+            <a:off x="3584448" y="685800"/>
             <a:ext cx="36576" cy="146304"/>
           </a:xfrm>
           <a:prstGeom prst="rect">
@@ -27202,8 +27202,8 @@
         </p:nvSpPr>
         <p:spPr>
           <a:xfrm>
-            <a:off x="3502152" y="658368"/>
-            <a:ext cx="4389120" cy="201168"/>
+            <a:off x="3657600" y="658368"/>
+            <a:ext cx="585216" cy="201168"/>
           </a:xfrm>
           <a:prstGeom prst="rect">
             <a:avLst/>
@@ -27238,7 +27238,7 @@
         </p:nvCxnSpPr>
         <p:spPr>
           <a:xfrm>
-            <a:off x="3474720" y="1005840"/>
+            <a:off x="3630168" y="1005840"/>
             <a:ext cx="685800" cy="0"/>
           </a:xfrm>
           <a:prstGeom prst="line">
@@ -27275,7 +27275,7 @@
         </p:nvSpPr>
         <p:spPr>
           <a:xfrm>
-            <a:off x="3429000" y="1060704"/>
+            <a:off x="3584448" y="1060704"/>
             <a:ext cx="822960" cy="164592"/>
           </a:xfrm>
           <a:prstGeom prst="rect">
@@ -27311,7 +27311,7 @@
         </p:nvCxnSpPr>
         <p:spPr>
           <a:xfrm>
-            <a:off x="4343400" y="1005840"/>
+            <a:off x="4498848" y="1005840"/>
             <a:ext cx="685800" cy="0"/>
           </a:xfrm>
           <a:prstGeom prst="line">
@@ -27349,7 +27349,7 @@
         </p:nvSpPr>
         <p:spPr>
           <a:xfrm>
-            <a:off x="4297680" y="1060704"/>
+            <a:off x="4453128" y="1060704"/>
             <a:ext cx="822960" cy="164592"/>
           </a:xfrm>
           <a:prstGeom prst="rect">
@@ -27385,7 +27385,7 @@
         </p:nvCxnSpPr>
         <p:spPr>
           <a:xfrm>
-            <a:off x="5212080" y="1005840"/>
+            <a:off x="5367528" y="1005840"/>
             <a:ext cx="685800" cy="0"/>
           </a:xfrm>
           <a:prstGeom prst="line">
@@ -27423,7 +27423,7 @@
         </p:nvSpPr>
         <p:spPr>
           <a:xfrm>
-            <a:off x="5166360" y="1060704"/>
+            <a:off x="5321808" y="1060704"/>
             <a:ext cx="822960" cy="164592"/>
           </a:xfrm>
           <a:prstGeom prst="rect">
@@ -27504,7 +27504,7 @@
         <p:spPr>
           <a:xfrm>
             <a:off x="6519672" y="658368"/>
-            <a:ext cx="4389120" cy="201168"/>
+            <a:ext cx="1298448" cy="201168"/>
           </a:xfrm>
           <a:prstGeom prst="rect">
             <a:avLst/>
@@ -27782,7 +27782,7 @@
         <p:spPr>
           <a:xfrm>
             <a:off x="438912" y="1572768"/>
-            <a:ext cx="4389120" cy="201168"/>
+            <a:ext cx="2653589" cy="201168"/>
           </a:xfrm>
           <a:prstGeom prst="rect">
             <a:avLst/>
@@ -28271,7 +28271,7 @@
         <p:spPr>
           <a:xfrm>
             <a:off x="3090672" y="1572768"/>
-            <a:ext cx="4389120" cy="201168"/>
+            <a:ext cx="2938882" cy="201168"/>
           </a:xfrm>
           <a:prstGeom prst="rect">
             <a:avLst/>
@@ -29994,7 +29994,7 @@
         <p:spPr>
           <a:xfrm>
             <a:off x="438912" y="2715768"/>
-            <a:ext cx="4389120" cy="201168"/>
+            <a:ext cx="4080053" cy="201168"/>
           </a:xfrm>
           <a:prstGeom prst="rect">
             <a:avLst/>
@@ -30162,7 +30162,7 @@
         <p:spPr>
           <a:xfrm>
             <a:off x="365760" y="3849624"/>
-            <a:ext cx="2194560" cy="182880"/>
+            <a:ext cx="2103120" cy="182880"/>
           </a:xfrm>
           <a:prstGeom prst="rect">
             <a:avLst/>
@@ -30487,7 +30487,7 @@
         <p:spPr>
           <a:xfrm>
             <a:off x="2514600" y="3849624"/>
-            <a:ext cx="2743200" cy="182880"/>
+            <a:ext cx="2377440" cy="182880"/>
           </a:xfrm>
           <a:prstGeom prst="rect">
             <a:avLst/>
@@ -30940,7 +30940,7 @@
         <p:spPr>
           <a:xfrm>
             <a:off x="438912" y="4498848"/>
-            <a:ext cx="4389120" cy="201168"/>
+            <a:ext cx="1869034" cy="201168"/>
           </a:xfrm>
           <a:prstGeom prst="rect">
             <a:avLst/>
@@ -31727,7 +31727,7 @@
         <p:spPr>
           <a:xfrm>
             <a:off x="5193792" y="4498848"/>
-            <a:ext cx="4389120" cy="201168"/>
+            <a:ext cx="1869034" cy="201168"/>
           </a:xfrm>
           <a:prstGeom prst="rect">
             <a:avLst/>
@@ -32803,7 +32803,7 @@
         <p:spPr>
           <a:xfrm>
             <a:off x="438912" y="621792"/>
-            <a:ext cx="4389120" cy="201168"/>
+            <a:ext cx="2867558" cy="201168"/>
           </a:xfrm>
           <a:prstGeom prst="rect">
             <a:avLst/>
@@ -35452,7 +35452,7 @@
         <p:spPr>
           <a:xfrm>
             <a:off x="438912" y="2724912"/>
-            <a:ext cx="4389120" cy="201168"/>
+            <a:ext cx="1869034" cy="201168"/>
           </a:xfrm>
           <a:prstGeom prst="rect">
             <a:avLst/>
@@ -35487,7 +35487,7 @@
         </p:nvSpPr>
         <p:spPr>
           <a:xfrm>
-            <a:off x="384048" y="2907792"/>
+            <a:off x="384048" y="2935224"/>
             <a:ext cx="4023360" cy="146304"/>
           </a:xfrm>
           <a:prstGeom prst="rect">
@@ -37028,7 +37028,7 @@
         <p:spPr>
           <a:xfrm>
             <a:off x="548640" y="4974336"/>
-            <a:ext cx="1005840" cy="164592"/>
+            <a:ext cx="685800" cy="164592"/>
           </a:xfrm>
           <a:prstGeom prst="rect">
             <a:avLst/>
@@ -37190,7 +37190,7 @@
         <p:spPr>
           <a:xfrm>
             <a:off x="4782312" y="2724912"/>
-            <a:ext cx="4389120" cy="201168"/>
+            <a:ext cx="1227125" cy="201168"/>
           </a:xfrm>
           <a:prstGeom prst="rect">
             <a:avLst/>
@@ -37225,7 +37225,7 @@
         </p:nvSpPr>
         <p:spPr>
           <a:xfrm>
-            <a:off x="4727448" y="2898648"/>
+            <a:off x="4727448" y="2935224"/>
             <a:ext cx="3017520" cy="274320"/>
           </a:xfrm>
           <a:prstGeom prst="rect">
@@ -39618,7 +39618,7 @@
         <p:spPr>
           <a:xfrm>
             <a:off x="4782312" y="5614416"/>
-            <a:ext cx="4389120" cy="201168"/>
+            <a:ext cx="1797710" cy="201168"/>
           </a:xfrm>
           <a:prstGeom prst="rect">
             <a:avLst/>
@@ -39792,7 +39792,7 @@
         <p:spPr>
           <a:xfrm>
             <a:off x="8074152" y="2724912"/>
-            <a:ext cx="3980383" cy="201168"/>
+            <a:ext cx="2796235" cy="201168"/>
           </a:xfrm>
           <a:prstGeom prst="rect">
             <a:avLst/>
@@ -40228,7 +40228,7 @@
         <p:spPr>
           <a:xfrm>
             <a:off x="438912" y="5138928"/>
-            <a:ext cx="4389120" cy="201168"/>
+            <a:ext cx="3295498" cy="201168"/>
           </a:xfrm>
           <a:prstGeom prst="rect">
             <a:avLst/>
@@ -40780,7 +40780,7 @@
         <p:spPr>
           <a:xfrm>
             <a:off x="438912" y="5980176"/>
-            <a:ext cx="4389120" cy="201168"/>
+            <a:ext cx="2938882" cy="201168"/>
           </a:xfrm>
           <a:prstGeom prst="rect">
             <a:avLst/>
@@ -41023,7 +41023,7 @@
         <p:spPr>
           <a:xfrm>
             <a:off x="8074152" y="5138928"/>
-            <a:ext cx="3980383" cy="201168"/>
+            <a:ext cx="3295498" cy="201168"/>
           </a:xfrm>
           <a:prstGeom prst="rect">
             <a:avLst/>

</xml_diff>